<commit_message>
roadmap doc: caveat theme update
</commit_message>
<xml_diff>
--- a/ugent/doc/roadmap.pptx
+++ b/ugent/doc/roadmap.pptx
@@ -5,7 +5,7 @@
     <p:sldMasterId id="2147483648" r:id="rId1"/>
   </p:sldMasterIdLst>
   <p:notesMasterIdLst>
-    <p:notesMasterId r:id="rId19"/>
+    <p:notesMasterId r:id="rId20"/>
   </p:notesMasterIdLst>
   <p:sldIdLst>
     <p:sldId id="256" r:id="rId2"/>
@@ -25,6 +25,7 @@
     <p:sldId id="263" r:id="rId16"/>
     <p:sldId id="265" r:id="rId17"/>
     <p:sldId id="266" r:id="rId18"/>
+    <p:sldId id="278" r:id="rId19"/>
   </p:sldIdLst>
   <p:sldSz cx="12192000" cy="6858000"/>
   <p:notesSz cx="6858000" cy="9144000"/>
@@ -213,7 +214,7 @@
           <a:p>
             <a:fld id="{0D2A5CE7-9F64-334A-AF08-0030E7084C74}" type="datetimeFigureOut">
               <a:rPr lang="en-BE" smtClean="0"/>
-              <a:t>01/10/2025</a:t>
+              <a:t>02/10/2025</a:t>
             </a:fld>
             <a:endParaRPr lang="en-BE"/>
           </a:p>
@@ -1359,7 +1360,7 @@
           <a:p>
             <a:fld id="{CEBB4FA6-D472-524D-9E47-34EB83AA8DAA}" type="datetimeFigureOut">
               <a:rPr lang="en-US" smtClean="0"/>
-              <a:t>10/1/25</a:t>
+              <a:t>10/2/25</a:t>
             </a:fld>
             <a:endParaRPr lang="en-US"/>
           </a:p>
@@ -1557,7 +1558,7 @@
           <a:p>
             <a:fld id="{CEBB4FA6-D472-524D-9E47-34EB83AA8DAA}" type="datetimeFigureOut">
               <a:rPr lang="en-US" smtClean="0"/>
-              <a:t>10/1/25</a:t>
+              <a:t>10/2/25</a:t>
             </a:fld>
             <a:endParaRPr lang="en-US"/>
           </a:p>
@@ -1765,7 +1766,7 @@
           <a:p>
             <a:fld id="{CEBB4FA6-D472-524D-9E47-34EB83AA8DAA}" type="datetimeFigureOut">
               <a:rPr lang="en-US" smtClean="0"/>
-              <a:t>10/1/25</a:t>
+              <a:t>10/2/25</a:t>
             </a:fld>
             <a:endParaRPr lang="en-US"/>
           </a:p>
@@ -1963,7 +1964,7 @@
           <a:p>
             <a:fld id="{CEBB4FA6-D472-524D-9E47-34EB83AA8DAA}" type="datetimeFigureOut">
               <a:rPr lang="en-US" smtClean="0"/>
-              <a:t>10/1/25</a:t>
+              <a:t>10/2/25</a:t>
             </a:fld>
             <a:endParaRPr lang="en-US"/>
           </a:p>
@@ -2238,7 +2239,7 @@
           <a:p>
             <a:fld id="{CEBB4FA6-D472-524D-9E47-34EB83AA8DAA}" type="datetimeFigureOut">
               <a:rPr lang="en-US" smtClean="0"/>
-              <a:t>10/1/25</a:t>
+              <a:t>10/2/25</a:t>
             </a:fld>
             <a:endParaRPr lang="en-US"/>
           </a:p>
@@ -2503,7 +2504,7 @@
           <a:p>
             <a:fld id="{CEBB4FA6-D472-524D-9E47-34EB83AA8DAA}" type="datetimeFigureOut">
               <a:rPr lang="en-US" smtClean="0"/>
-              <a:t>10/1/25</a:t>
+              <a:t>10/2/25</a:t>
             </a:fld>
             <a:endParaRPr lang="en-US"/>
           </a:p>
@@ -2915,7 +2916,7 @@
           <a:p>
             <a:fld id="{CEBB4FA6-D472-524D-9E47-34EB83AA8DAA}" type="datetimeFigureOut">
               <a:rPr lang="en-US" smtClean="0"/>
-              <a:t>10/1/25</a:t>
+              <a:t>10/2/25</a:t>
             </a:fld>
             <a:endParaRPr lang="en-US"/>
           </a:p>
@@ -3056,7 +3057,7 @@
           <a:p>
             <a:fld id="{CEBB4FA6-D472-524D-9E47-34EB83AA8DAA}" type="datetimeFigureOut">
               <a:rPr lang="en-US" smtClean="0"/>
-              <a:t>10/1/25</a:t>
+              <a:t>10/2/25</a:t>
             </a:fld>
             <a:endParaRPr lang="en-US"/>
           </a:p>
@@ -3169,7 +3170,7 @@
           <a:p>
             <a:fld id="{CEBB4FA6-D472-524D-9E47-34EB83AA8DAA}" type="datetimeFigureOut">
               <a:rPr lang="en-US" smtClean="0"/>
-              <a:t>10/1/25</a:t>
+              <a:t>10/2/25</a:t>
             </a:fld>
             <a:endParaRPr lang="en-US"/>
           </a:p>
@@ -3480,7 +3481,7 @@
           <a:p>
             <a:fld id="{CEBB4FA6-D472-524D-9E47-34EB83AA8DAA}" type="datetimeFigureOut">
               <a:rPr lang="en-US" smtClean="0"/>
-              <a:t>10/1/25</a:t>
+              <a:t>10/2/25</a:t>
             </a:fld>
             <a:endParaRPr lang="en-US"/>
           </a:p>
@@ -3768,7 +3769,7 @@
           <a:p>
             <a:fld id="{CEBB4FA6-D472-524D-9E47-34EB83AA8DAA}" type="datetimeFigureOut">
               <a:rPr lang="en-US" smtClean="0"/>
-              <a:t>10/1/25</a:t>
+              <a:t>10/2/25</a:t>
             </a:fld>
             <a:endParaRPr lang="en-US"/>
           </a:p>
@@ -4009,7 +4010,7 @@
           <a:p>
             <a:fld id="{CEBB4FA6-D472-524D-9E47-34EB83AA8DAA}" type="datetimeFigureOut">
               <a:rPr lang="en-US" smtClean="0"/>
-              <a:t>10/1/25</a:t>
+              <a:t>10/2/25</a:t>
             </a:fld>
             <a:endParaRPr lang="en-US"/>
           </a:p>
@@ -5476,6 +5477,109 @@
     <p:extLst>
       <p:ext uri="{BB962C8B-B14F-4D97-AF65-F5344CB8AC3E}">
         <p14:creationId xmlns:p14="http://schemas.microsoft.com/office/powerpoint/2010/main" val="2942233035"/>
+      </p:ext>
+    </p:extLst>
+  </p:cSld>
+  <p:clrMapOvr>
+    <a:masterClrMapping/>
+  </p:clrMapOvr>
+</p:sld>
+</file>
+
+<file path=ppt/slides/slide18.xml><?xml version="1.0" encoding="utf-8"?>
+<p:sld xmlns:a="http://schemas.openxmlformats.org/drawingml/2006/main" xmlns:r="http://schemas.openxmlformats.org/officeDocument/2006/relationships" xmlns:p="http://schemas.openxmlformats.org/presentationml/2006/main">
+  <p:cSld>
+    <p:spTree>
+      <p:nvGrpSpPr>
+        <p:cNvPr id="1" name=""/>
+        <p:cNvGrpSpPr/>
+        <p:nvPr/>
+      </p:nvGrpSpPr>
+      <p:grpSpPr>
+        <a:xfrm>
+          <a:off x="0" y="0"/>
+          <a:ext cx="0" cy="0"/>
+          <a:chOff x="0" y="0"/>
+          <a:chExt cx="0" cy="0"/>
+        </a:xfrm>
+      </p:grpSpPr>
+      <p:sp>
+        <p:nvSpPr>
+          <p:cNvPr id="2" name="Title 1">
+            <a:extLst>
+              <a:ext uri="{FF2B5EF4-FFF2-40B4-BE49-F238E27FC236}">
+                <a16:creationId xmlns:a16="http://schemas.microsoft.com/office/drawing/2014/main" id="{713ED5C9-3813-A929-CCCF-8E42CAA29628}"/>
+              </a:ext>
+            </a:extLst>
+          </p:cNvPr>
+          <p:cNvSpPr>
+            <a:spLocks noGrp="1"/>
+          </p:cNvSpPr>
+          <p:nvPr>
+            <p:ph type="title"/>
+          </p:nvPr>
+        </p:nvSpPr>
+        <p:spPr/>
+        <p:txBody>
+          <a:bodyPr/>
+          <a:lstStyle/>
+          <a:p>
+            <a:r>
+              <a:rPr lang="en-BE" dirty="0"/>
+              <a:t>Caveat: update theme not versioned</a:t>
+            </a:r>
+          </a:p>
+        </p:txBody>
+      </p:sp>
+      <p:sp>
+        <p:nvSpPr>
+          <p:cNvPr id="3" name="Content Placeholder 2">
+            <a:extLst>
+              <a:ext uri="{FF2B5EF4-FFF2-40B4-BE49-F238E27FC236}">
+                <a16:creationId xmlns:a16="http://schemas.microsoft.com/office/drawing/2014/main" id="{D6EE6F71-F45C-E0E0-6171-97889EF013A3}"/>
+              </a:ext>
+            </a:extLst>
+          </p:cNvPr>
+          <p:cNvSpPr>
+            <a:spLocks noGrp="1"/>
+          </p:cNvSpPr>
+          <p:nvPr>
+            <p:ph idx="1"/>
+          </p:nvPr>
+        </p:nvSpPr>
+        <p:spPr/>
+        <p:txBody>
+          <a:bodyPr/>
+          <a:lstStyle/>
+          <a:p>
+            <a:r>
+              <a:rPr lang="en-BE" dirty="0"/>
+              <a:t>add a guidance to a theme, and you it in every plan that uses that theme.</a:t>
+            </a:r>
+          </a:p>
+          <a:p>
+            <a:r>
+              <a:rPr lang="en-BE" dirty="0"/>
+              <a:t>delete a guidance from a theme, and it dissappears from every plan that uses that theme</a:t>
+            </a:r>
+          </a:p>
+          <a:p>
+            <a:r>
+              <a:rPr lang="en-BE" dirty="0"/>
+              <a:t>Problem? Guidance by </a:t>
+            </a:r>
+            <a:r>
+              <a:rPr lang="en-BE"/>
+              <a:t>guidance group is also dynamic</a:t>
+            </a:r>
+            <a:endParaRPr lang="en-BE" dirty="0"/>
+          </a:p>
+        </p:txBody>
+      </p:sp>
+    </p:spTree>
+    <p:extLst>
+      <p:ext uri="{BB962C8B-B14F-4D97-AF65-F5344CB8AC3E}">
+        <p14:creationId xmlns:p14="http://schemas.microsoft.com/office/powerpoint/2010/main" val="2674048192"/>
       </p:ext>
     </p:extLst>
   </p:cSld>

</xml_diff>

<commit_message>
doc roadmap: add phase to diagram
</commit_message>
<xml_diff>
--- a/ugent/doc/roadmap.pptx
+++ b/ugent/doc/roadmap.pptx
@@ -5810,7 +5810,7 @@
             <a:pPr algn="ctr"/>
             <a:r>
               <a:rPr lang="en-BE" dirty="0"/>
-              <a:t>Section</a:t>
+              <a:t>Phase</a:t>
             </a:r>
           </a:p>
         </p:txBody>
@@ -5859,7 +5859,7 @@
             <a:pPr algn="ctr"/>
             <a:r>
               <a:rPr lang="en-BE" dirty="0"/>
-              <a:t>Question</a:t>
+              <a:t>Section</a:t>
             </a:r>
           </a:p>
         </p:txBody>
@@ -6083,6 +6083,166 @@
             <a:r>
               <a:rPr lang="en-BE" dirty="0"/>
               <a:t>1</a:t>
+            </a:r>
+          </a:p>
+        </p:txBody>
+      </p:sp>
+      <p:sp>
+        <p:nvSpPr>
+          <p:cNvPr id="4" name="Process 3">
+            <a:extLst>
+              <a:ext uri="{FF2B5EF4-FFF2-40B4-BE49-F238E27FC236}">
+                <a16:creationId xmlns:a16="http://schemas.microsoft.com/office/drawing/2014/main" id="{6E6D12BA-457C-5C4F-3E7B-CFB349C6EE5A}"/>
+              </a:ext>
+            </a:extLst>
+          </p:cNvPr>
+          <p:cNvSpPr/>
+          <p:nvPr/>
+        </p:nvSpPr>
+        <p:spPr>
+          <a:xfrm>
+            <a:off x="9297429" y="4367209"/>
+            <a:ext cx="2063580" cy="840259"/>
+          </a:xfrm>
+          <a:prstGeom prst="flowChartProcess">
+            <a:avLst/>
+          </a:prstGeom>
+        </p:spPr>
+        <p:style>
+          <a:lnRef idx="2">
+            <a:schemeClr val="accent1">
+              <a:shade val="15000"/>
+            </a:schemeClr>
+          </a:lnRef>
+          <a:fillRef idx="1">
+            <a:schemeClr val="accent1"/>
+          </a:fillRef>
+          <a:effectRef idx="0">
+            <a:schemeClr val="accent1"/>
+          </a:effectRef>
+          <a:fontRef idx="minor">
+            <a:schemeClr val="lt1"/>
+          </a:fontRef>
+        </p:style>
+        <p:txBody>
+          <a:bodyPr rtlCol="0" anchor="ctr"/>
+          <a:lstStyle/>
+          <a:p>
+            <a:pPr algn="ctr"/>
+            <a:r>
+              <a:rPr lang="en-BE" dirty="0"/>
+              <a:t>Question</a:t>
+            </a:r>
+          </a:p>
+        </p:txBody>
+      </p:sp>
+      <p:cxnSp>
+        <p:nvCxnSpPr>
+          <p:cNvPr id="6" name="Elbow Connector 5">
+            <a:extLst>
+              <a:ext uri="{FF2B5EF4-FFF2-40B4-BE49-F238E27FC236}">
+                <a16:creationId xmlns:a16="http://schemas.microsoft.com/office/drawing/2014/main" id="{C4B47B30-6EB7-973E-42C3-0C43E17F8778}"/>
+              </a:ext>
+            </a:extLst>
+          </p:cNvPr>
+          <p:cNvCxnSpPr>
+            <a:stCxn id="15" idx="2"/>
+          </p:cNvCxnSpPr>
+          <p:nvPr/>
+        </p:nvCxnSpPr>
+        <p:spPr>
+          <a:xfrm rot="5400000">
+            <a:off x="9767438" y="3805428"/>
+            <a:ext cx="1123562" cy="12700"/>
+          </a:xfrm>
+          <a:prstGeom prst="bentConnector3">
+            <a:avLst/>
+          </a:prstGeom>
+          <a:ln>
+            <a:tailEnd type="triangle"/>
+          </a:ln>
+        </p:spPr>
+        <p:style>
+          <a:lnRef idx="1">
+            <a:schemeClr val="accent1"/>
+          </a:lnRef>
+          <a:fillRef idx="0">
+            <a:schemeClr val="accent1"/>
+          </a:fillRef>
+          <a:effectRef idx="0">
+            <a:schemeClr val="accent1"/>
+          </a:effectRef>
+          <a:fontRef idx="minor">
+            <a:schemeClr val="tx1"/>
+          </a:fontRef>
+        </p:style>
+      </p:cxnSp>
+      <p:sp>
+        <p:nvSpPr>
+          <p:cNvPr id="7" name="TextBox 6">
+            <a:extLst>
+              <a:ext uri="{FF2B5EF4-FFF2-40B4-BE49-F238E27FC236}">
+                <a16:creationId xmlns:a16="http://schemas.microsoft.com/office/drawing/2014/main" id="{15315E82-132C-3B84-670E-C94D99164C5A}"/>
+              </a:ext>
+            </a:extLst>
+          </p:cNvPr>
+          <p:cNvSpPr txBox="1"/>
+          <p:nvPr/>
+        </p:nvSpPr>
+        <p:spPr>
+          <a:xfrm>
+            <a:off x="10030683" y="3283515"/>
+            <a:ext cx="332509" cy="369332"/>
+          </a:xfrm>
+          <a:prstGeom prst="rect">
+            <a:avLst/>
+          </a:prstGeom>
+          <a:noFill/>
+        </p:spPr>
+        <p:txBody>
+          <a:bodyPr wrap="square" rtlCol="0">
+            <a:spAutoFit/>
+          </a:bodyPr>
+          <a:lstStyle/>
+          <a:p>
+            <a:r>
+              <a:rPr lang="en-BE" dirty="0"/>
+              <a:t>1</a:t>
+            </a:r>
+          </a:p>
+        </p:txBody>
+      </p:sp>
+      <p:sp>
+        <p:nvSpPr>
+          <p:cNvPr id="8" name="TextBox 7">
+            <a:extLst>
+              <a:ext uri="{FF2B5EF4-FFF2-40B4-BE49-F238E27FC236}">
+                <a16:creationId xmlns:a16="http://schemas.microsoft.com/office/drawing/2014/main" id="{2F38A915-474E-6286-77BA-369B2470244F}"/>
+              </a:ext>
+            </a:extLst>
+          </p:cNvPr>
+          <p:cNvSpPr txBox="1"/>
+          <p:nvPr/>
+        </p:nvSpPr>
+        <p:spPr>
+          <a:xfrm>
+            <a:off x="10460193" y="3962399"/>
+            <a:ext cx="332509" cy="369332"/>
+          </a:xfrm>
+          <a:prstGeom prst="rect">
+            <a:avLst/>
+          </a:prstGeom>
+          <a:noFill/>
+        </p:spPr>
+        <p:txBody>
+          <a:bodyPr wrap="square" rtlCol="0">
+            <a:spAutoFit/>
+          </a:bodyPr>
+          <a:lstStyle/>
+          <a:p>
+            <a:r>
+              <a:rPr lang="en-BE" dirty="0"/>
+              <a:t>N</a:t>
             </a:r>
           </a:p>
         </p:txBody>
@@ -8019,55 +8179,6 @@
       </p:sp>
       <p:sp>
         <p:nvSpPr>
-          <p:cNvPr id="8" name="Process 7">
-            <a:extLst>
-              <a:ext uri="{FF2B5EF4-FFF2-40B4-BE49-F238E27FC236}">
-                <a16:creationId xmlns:a16="http://schemas.microsoft.com/office/drawing/2014/main" id="{351C0765-1D40-16A9-BCA2-714D3400C791}"/>
-              </a:ext>
-            </a:extLst>
-          </p:cNvPr>
-          <p:cNvSpPr/>
-          <p:nvPr/>
-        </p:nvSpPr>
-        <p:spPr>
-          <a:xfrm>
-            <a:off x="5064210" y="4284611"/>
-            <a:ext cx="2063580" cy="821724"/>
-          </a:xfrm>
-          <a:prstGeom prst="flowChartProcess">
-            <a:avLst/>
-          </a:prstGeom>
-        </p:spPr>
-        <p:style>
-          <a:lnRef idx="2">
-            <a:schemeClr val="accent1">
-              <a:shade val="15000"/>
-            </a:schemeClr>
-          </a:lnRef>
-          <a:fillRef idx="1">
-            <a:schemeClr val="accent1"/>
-          </a:fillRef>
-          <a:effectRef idx="0">
-            <a:schemeClr val="accent1"/>
-          </a:effectRef>
-          <a:fontRef idx="minor">
-            <a:schemeClr val="lt1"/>
-          </a:fontRef>
-        </p:style>
-        <p:txBody>
-          <a:bodyPr rtlCol="0" anchor="ctr"/>
-          <a:lstStyle/>
-          <a:p>
-            <a:pPr algn="ctr"/>
-            <a:r>
-              <a:rPr lang="en-BE" dirty="0"/>
-              <a:t>Section</a:t>
-            </a:r>
-          </a:p>
-        </p:txBody>
-      </p:sp>
-      <p:sp>
-        <p:nvSpPr>
           <p:cNvPr id="9" name="Process 8">
             <a:extLst>
               <a:ext uri="{FF2B5EF4-FFF2-40B4-BE49-F238E27FC236}">
@@ -8111,229 +8222,6 @@
             <a:r>
               <a:rPr lang="en-BE" dirty="0"/>
               <a:t>Question</a:t>
-            </a:r>
-          </a:p>
-        </p:txBody>
-      </p:sp>
-      <p:cxnSp>
-        <p:nvCxnSpPr>
-          <p:cNvPr id="10" name="Elbow Connector 9">
-            <a:extLst>
-              <a:ext uri="{FF2B5EF4-FFF2-40B4-BE49-F238E27FC236}">
-                <a16:creationId xmlns:a16="http://schemas.microsoft.com/office/drawing/2014/main" id="{EFFAE442-F39F-64DE-642E-A09B8E91BA05}"/>
-              </a:ext>
-            </a:extLst>
-          </p:cNvPr>
-          <p:cNvCxnSpPr>
-            <a:stCxn id="7" idx="3"/>
-            <a:endCxn id="8" idx="1"/>
-          </p:cNvCxnSpPr>
-          <p:nvPr/>
-        </p:nvCxnSpPr>
-        <p:spPr>
-          <a:xfrm flipV="1">
-            <a:off x="2887361" y="4695473"/>
-            <a:ext cx="2176849" cy="3089"/>
-          </a:xfrm>
-          <a:prstGeom prst="bentConnector3">
-            <a:avLst/>
-          </a:prstGeom>
-          <a:ln>
-            <a:tailEnd type="triangle"/>
-          </a:ln>
-        </p:spPr>
-        <p:style>
-          <a:lnRef idx="1">
-            <a:schemeClr val="accent1"/>
-          </a:lnRef>
-          <a:fillRef idx="0">
-            <a:schemeClr val="accent1"/>
-          </a:fillRef>
-          <a:effectRef idx="0">
-            <a:schemeClr val="accent1"/>
-          </a:effectRef>
-          <a:fontRef idx="minor">
-            <a:schemeClr val="tx1"/>
-          </a:fontRef>
-        </p:style>
-      </p:cxnSp>
-      <p:cxnSp>
-        <p:nvCxnSpPr>
-          <p:cNvPr id="11" name="Elbow Connector 10">
-            <a:extLst>
-              <a:ext uri="{FF2B5EF4-FFF2-40B4-BE49-F238E27FC236}">
-                <a16:creationId xmlns:a16="http://schemas.microsoft.com/office/drawing/2014/main" id="{F3A5A337-00A6-D2BE-B227-768103467DD1}"/>
-              </a:ext>
-            </a:extLst>
-          </p:cNvPr>
-          <p:cNvCxnSpPr>
-            <a:endCxn id="9" idx="1"/>
-          </p:cNvCxnSpPr>
-          <p:nvPr/>
-        </p:nvCxnSpPr>
-        <p:spPr>
-          <a:xfrm>
-            <a:off x="7116976" y="4670759"/>
-            <a:ext cx="2173244" cy="9268"/>
-          </a:xfrm>
-          <a:prstGeom prst="bentConnector3">
-            <a:avLst/>
-          </a:prstGeom>
-          <a:ln>
-            <a:tailEnd type="triangle"/>
-          </a:ln>
-        </p:spPr>
-        <p:style>
-          <a:lnRef idx="1">
-            <a:schemeClr val="accent1"/>
-          </a:lnRef>
-          <a:fillRef idx="0">
-            <a:schemeClr val="accent1"/>
-          </a:fillRef>
-          <a:effectRef idx="0">
-            <a:schemeClr val="accent1"/>
-          </a:effectRef>
-          <a:fontRef idx="minor">
-            <a:schemeClr val="tx1"/>
-          </a:fontRef>
-        </p:style>
-      </p:cxnSp>
-      <p:sp>
-        <p:nvSpPr>
-          <p:cNvPr id="12" name="TextBox 11">
-            <a:extLst>
-              <a:ext uri="{FF2B5EF4-FFF2-40B4-BE49-F238E27FC236}">
-                <a16:creationId xmlns:a16="http://schemas.microsoft.com/office/drawing/2014/main" id="{5DFA5A9C-13CF-82AE-4247-C392240584A8}"/>
-              </a:ext>
-            </a:extLst>
-          </p:cNvPr>
-          <p:cNvSpPr txBox="1"/>
-          <p:nvPr/>
-        </p:nvSpPr>
-        <p:spPr>
-          <a:xfrm>
-            <a:off x="4606359" y="4779814"/>
-            <a:ext cx="332509" cy="369332"/>
-          </a:xfrm>
-          <a:prstGeom prst="rect">
-            <a:avLst/>
-          </a:prstGeom>
-          <a:noFill/>
-        </p:spPr>
-        <p:txBody>
-          <a:bodyPr wrap="square" rtlCol="0">
-            <a:spAutoFit/>
-          </a:bodyPr>
-          <a:lstStyle/>
-          <a:p>
-            <a:r>
-              <a:rPr lang="en-BE" dirty="0"/>
-              <a:t>N</a:t>
-            </a:r>
-          </a:p>
-        </p:txBody>
-      </p:sp>
-      <p:sp>
-        <p:nvSpPr>
-          <p:cNvPr id="13" name="TextBox 12">
-            <a:extLst>
-              <a:ext uri="{FF2B5EF4-FFF2-40B4-BE49-F238E27FC236}">
-                <a16:creationId xmlns:a16="http://schemas.microsoft.com/office/drawing/2014/main" id="{51FEE989-2FDC-A38F-2507-51F3EAF238C4}"/>
-              </a:ext>
-            </a:extLst>
-          </p:cNvPr>
-          <p:cNvSpPr txBox="1"/>
-          <p:nvPr/>
-        </p:nvSpPr>
-        <p:spPr>
-          <a:xfrm>
-            <a:off x="8859707" y="4821374"/>
-            <a:ext cx="332509" cy="369332"/>
-          </a:xfrm>
-          <a:prstGeom prst="rect">
-            <a:avLst/>
-          </a:prstGeom>
-          <a:noFill/>
-        </p:spPr>
-        <p:txBody>
-          <a:bodyPr wrap="square" rtlCol="0">
-            <a:spAutoFit/>
-          </a:bodyPr>
-          <a:lstStyle/>
-          <a:p>
-            <a:r>
-              <a:rPr lang="en-BE" dirty="0"/>
-              <a:t>N</a:t>
-            </a:r>
-          </a:p>
-        </p:txBody>
-      </p:sp>
-      <p:sp>
-        <p:nvSpPr>
-          <p:cNvPr id="14" name="TextBox 13">
-            <a:extLst>
-              <a:ext uri="{FF2B5EF4-FFF2-40B4-BE49-F238E27FC236}">
-                <a16:creationId xmlns:a16="http://schemas.microsoft.com/office/drawing/2014/main" id="{C6F977BE-66EF-0149-4418-94E1702E7707}"/>
-              </a:ext>
-            </a:extLst>
-          </p:cNvPr>
-          <p:cNvSpPr txBox="1"/>
-          <p:nvPr/>
-        </p:nvSpPr>
-        <p:spPr>
-          <a:xfrm>
-            <a:off x="2985367" y="4821374"/>
-            <a:ext cx="332509" cy="369332"/>
-          </a:xfrm>
-          <a:prstGeom prst="rect">
-            <a:avLst/>
-          </a:prstGeom>
-          <a:noFill/>
-        </p:spPr>
-        <p:txBody>
-          <a:bodyPr wrap="square" rtlCol="0">
-            <a:spAutoFit/>
-          </a:bodyPr>
-          <a:lstStyle/>
-          <a:p>
-            <a:r>
-              <a:rPr lang="en-BE" dirty="0"/>
-              <a:t>1</a:t>
-            </a:r>
-          </a:p>
-        </p:txBody>
-      </p:sp>
-      <p:sp>
-        <p:nvSpPr>
-          <p:cNvPr id="15" name="TextBox 14">
-            <a:extLst>
-              <a:ext uri="{FF2B5EF4-FFF2-40B4-BE49-F238E27FC236}">
-                <a16:creationId xmlns:a16="http://schemas.microsoft.com/office/drawing/2014/main" id="{634787B7-76F9-C91E-BBE3-76697F6329C6}"/>
-              </a:ext>
-            </a:extLst>
-          </p:cNvPr>
-          <p:cNvSpPr txBox="1"/>
-          <p:nvPr/>
-        </p:nvSpPr>
-        <p:spPr>
-          <a:xfrm>
-            <a:off x="7155584" y="4793659"/>
-            <a:ext cx="332509" cy="369332"/>
-          </a:xfrm>
-          <a:prstGeom prst="rect">
-            <a:avLst/>
-          </a:prstGeom>
-          <a:noFill/>
-        </p:spPr>
-        <p:txBody>
-          <a:bodyPr wrap="square" rtlCol="0">
-            <a:spAutoFit/>
-          </a:bodyPr>
-          <a:lstStyle/>
-          <a:p>
-            <a:r>
-              <a:rPr lang="en-BE" dirty="0"/>
-              <a:t>1</a:t>
             </a:r>
           </a:p>
         </p:txBody>
@@ -8670,6 +8558,440 @@
             <a:r>
               <a:rPr lang="en-BE" dirty="0"/>
               <a:t>1</a:t>
+            </a:r>
+          </a:p>
+        </p:txBody>
+      </p:sp>
+      <p:sp>
+        <p:nvSpPr>
+          <p:cNvPr id="3" name="Process 2">
+            <a:extLst>
+              <a:ext uri="{FF2B5EF4-FFF2-40B4-BE49-F238E27FC236}">
+                <a16:creationId xmlns:a16="http://schemas.microsoft.com/office/drawing/2014/main" id="{B12B445F-4D96-E499-31B8-09467D13973C}"/>
+              </a:ext>
+            </a:extLst>
+          </p:cNvPr>
+          <p:cNvSpPr/>
+          <p:nvPr/>
+        </p:nvSpPr>
+        <p:spPr>
+          <a:xfrm>
+            <a:off x="3566982" y="5492951"/>
+            <a:ext cx="2063579" cy="877329"/>
+          </a:xfrm>
+          <a:prstGeom prst="flowChartProcess">
+            <a:avLst/>
+          </a:prstGeom>
+        </p:spPr>
+        <p:style>
+          <a:lnRef idx="2">
+            <a:schemeClr val="accent1">
+              <a:shade val="15000"/>
+            </a:schemeClr>
+          </a:lnRef>
+          <a:fillRef idx="1">
+            <a:schemeClr val="accent1"/>
+          </a:fillRef>
+          <a:effectRef idx="0">
+            <a:schemeClr val="accent1"/>
+          </a:effectRef>
+          <a:fontRef idx="minor">
+            <a:schemeClr val="lt1"/>
+          </a:fontRef>
+        </p:style>
+        <p:txBody>
+          <a:bodyPr rtlCol="0" anchor="ctr"/>
+          <a:lstStyle/>
+          <a:p>
+            <a:pPr algn="ctr"/>
+            <a:r>
+              <a:rPr lang="en-BE" dirty="0"/>
+              <a:t>Phase</a:t>
+            </a:r>
+          </a:p>
+        </p:txBody>
+      </p:sp>
+      <p:sp>
+        <p:nvSpPr>
+          <p:cNvPr id="6" name="Process 5">
+            <a:extLst>
+              <a:ext uri="{FF2B5EF4-FFF2-40B4-BE49-F238E27FC236}">
+                <a16:creationId xmlns:a16="http://schemas.microsoft.com/office/drawing/2014/main" id="{7DFD847D-1E80-06B4-62FB-72F43E5E11B4}"/>
+              </a:ext>
+            </a:extLst>
+          </p:cNvPr>
+          <p:cNvSpPr/>
+          <p:nvPr/>
+        </p:nvSpPr>
+        <p:spPr>
+          <a:xfrm>
+            <a:off x="6837668" y="5425548"/>
+            <a:ext cx="2063579" cy="877329"/>
+          </a:xfrm>
+          <a:prstGeom prst="flowChartProcess">
+            <a:avLst/>
+          </a:prstGeom>
+        </p:spPr>
+        <p:style>
+          <a:lnRef idx="2">
+            <a:schemeClr val="accent1">
+              <a:shade val="15000"/>
+            </a:schemeClr>
+          </a:lnRef>
+          <a:fillRef idx="1">
+            <a:schemeClr val="accent1"/>
+          </a:fillRef>
+          <a:effectRef idx="0">
+            <a:schemeClr val="accent1"/>
+          </a:effectRef>
+          <a:fontRef idx="minor">
+            <a:schemeClr val="lt1"/>
+          </a:fontRef>
+        </p:style>
+        <p:txBody>
+          <a:bodyPr rtlCol="0" anchor="ctr"/>
+          <a:lstStyle/>
+          <a:p>
+            <a:pPr algn="ctr"/>
+            <a:r>
+              <a:rPr lang="en-BE" dirty="0"/>
+              <a:t>Section</a:t>
+            </a:r>
+          </a:p>
+        </p:txBody>
+      </p:sp>
+      <p:cxnSp>
+        <p:nvCxnSpPr>
+          <p:cNvPr id="17" name="Elbow Connector 16">
+            <a:extLst>
+              <a:ext uri="{FF2B5EF4-FFF2-40B4-BE49-F238E27FC236}">
+                <a16:creationId xmlns:a16="http://schemas.microsoft.com/office/drawing/2014/main" id="{3A4B7A09-28C2-41C1-6BD1-DBA2B6CE2392}"/>
+              </a:ext>
+            </a:extLst>
+          </p:cNvPr>
+          <p:cNvCxnSpPr>
+            <a:stCxn id="7" idx="2"/>
+            <a:endCxn id="3" idx="1"/>
+          </p:cNvCxnSpPr>
+          <p:nvPr/>
+        </p:nvCxnSpPr>
+        <p:spPr>
+          <a:xfrm rot="16200000" flipH="1">
+            <a:off x="2314082" y="4678716"/>
+            <a:ext cx="794390" cy="1711410"/>
+          </a:xfrm>
+          <a:prstGeom prst="bentConnector2">
+            <a:avLst/>
+          </a:prstGeom>
+          <a:ln>
+            <a:tailEnd type="triangle"/>
+          </a:ln>
+        </p:spPr>
+        <p:style>
+          <a:lnRef idx="1">
+            <a:schemeClr val="accent1"/>
+          </a:lnRef>
+          <a:fillRef idx="0">
+            <a:schemeClr val="accent1"/>
+          </a:fillRef>
+          <a:effectRef idx="0">
+            <a:schemeClr val="accent1"/>
+          </a:effectRef>
+          <a:fontRef idx="minor">
+            <a:schemeClr val="tx1"/>
+          </a:fontRef>
+        </p:style>
+      </p:cxnSp>
+      <p:cxnSp>
+        <p:nvCxnSpPr>
+          <p:cNvPr id="19" name="Elbow Connector 18">
+            <a:extLst>
+              <a:ext uri="{FF2B5EF4-FFF2-40B4-BE49-F238E27FC236}">
+                <a16:creationId xmlns:a16="http://schemas.microsoft.com/office/drawing/2014/main" id="{9B6DDAEA-47AF-CFFD-13FB-987222C2FABC}"/>
+              </a:ext>
+            </a:extLst>
+          </p:cNvPr>
+          <p:cNvCxnSpPr>
+            <a:stCxn id="3" idx="3"/>
+            <a:endCxn id="6" idx="1"/>
+          </p:cNvCxnSpPr>
+          <p:nvPr/>
+        </p:nvCxnSpPr>
+        <p:spPr>
+          <a:xfrm flipV="1">
+            <a:off x="5630561" y="5864213"/>
+            <a:ext cx="1207107" cy="67403"/>
+          </a:xfrm>
+          <a:prstGeom prst="bentConnector3">
+            <a:avLst/>
+          </a:prstGeom>
+          <a:ln>
+            <a:tailEnd type="triangle"/>
+          </a:ln>
+        </p:spPr>
+        <p:style>
+          <a:lnRef idx="1">
+            <a:schemeClr val="accent1"/>
+          </a:lnRef>
+          <a:fillRef idx="0">
+            <a:schemeClr val="accent1"/>
+          </a:fillRef>
+          <a:effectRef idx="0">
+            <a:schemeClr val="accent1"/>
+          </a:effectRef>
+          <a:fontRef idx="minor">
+            <a:schemeClr val="tx1"/>
+          </a:fontRef>
+        </p:style>
+      </p:cxnSp>
+      <p:cxnSp>
+        <p:nvCxnSpPr>
+          <p:cNvPr id="23" name="Elbow Connector 22">
+            <a:extLst>
+              <a:ext uri="{FF2B5EF4-FFF2-40B4-BE49-F238E27FC236}">
+                <a16:creationId xmlns:a16="http://schemas.microsoft.com/office/drawing/2014/main" id="{BCE9CE3C-86AC-FBB9-748D-27D9ABDBB3A4}"/>
+              </a:ext>
+            </a:extLst>
+          </p:cNvPr>
+          <p:cNvCxnSpPr>
+            <a:stCxn id="6" idx="3"/>
+            <a:endCxn id="9" idx="2"/>
+          </p:cNvCxnSpPr>
+          <p:nvPr/>
+        </p:nvCxnSpPr>
+        <p:spPr>
+          <a:xfrm flipV="1">
+            <a:off x="8901247" y="5100156"/>
+            <a:ext cx="1420763" cy="764057"/>
+          </a:xfrm>
+          <a:prstGeom prst="bentConnector2">
+            <a:avLst/>
+          </a:prstGeom>
+          <a:ln>
+            <a:tailEnd type="triangle"/>
+          </a:ln>
+        </p:spPr>
+        <p:style>
+          <a:lnRef idx="1">
+            <a:schemeClr val="accent1"/>
+          </a:lnRef>
+          <a:fillRef idx="0">
+            <a:schemeClr val="accent1"/>
+          </a:fillRef>
+          <a:effectRef idx="0">
+            <a:schemeClr val="accent1"/>
+          </a:effectRef>
+          <a:fontRef idx="minor">
+            <a:schemeClr val="tx1"/>
+          </a:fontRef>
+        </p:style>
+      </p:cxnSp>
+      <p:sp>
+        <p:nvSpPr>
+          <p:cNvPr id="31" name="TextBox 30">
+            <a:extLst>
+              <a:ext uri="{FF2B5EF4-FFF2-40B4-BE49-F238E27FC236}">
+                <a16:creationId xmlns:a16="http://schemas.microsoft.com/office/drawing/2014/main" id="{85675CF4-1005-4921-82F8-796E15657234}"/>
+              </a:ext>
+            </a:extLst>
+          </p:cNvPr>
+          <p:cNvSpPr txBox="1"/>
+          <p:nvPr/>
+        </p:nvSpPr>
+        <p:spPr>
+          <a:xfrm>
+            <a:off x="1544491" y="5167743"/>
+            <a:ext cx="332509" cy="369332"/>
+          </a:xfrm>
+          <a:prstGeom prst="rect">
+            <a:avLst/>
+          </a:prstGeom>
+          <a:noFill/>
+        </p:spPr>
+        <p:txBody>
+          <a:bodyPr wrap="square" rtlCol="0">
+            <a:spAutoFit/>
+          </a:bodyPr>
+          <a:lstStyle/>
+          <a:p>
+            <a:r>
+              <a:rPr lang="en-BE" dirty="0"/>
+              <a:t>1</a:t>
+            </a:r>
+          </a:p>
+        </p:txBody>
+      </p:sp>
+      <p:sp>
+        <p:nvSpPr>
+          <p:cNvPr id="32" name="TextBox 31">
+            <a:extLst>
+              <a:ext uri="{FF2B5EF4-FFF2-40B4-BE49-F238E27FC236}">
+                <a16:creationId xmlns:a16="http://schemas.microsoft.com/office/drawing/2014/main" id="{2308D8C9-B491-691D-11F5-79E1415087B4}"/>
+              </a:ext>
+            </a:extLst>
+          </p:cNvPr>
+          <p:cNvSpPr txBox="1"/>
+          <p:nvPr/>
+        </p:nvSpPr>
+        <p:spPr>
+          <a:xfrm>
+            <a:off x="5645440" y="5943595"/>
+            <a:ext cx="332509" cy="369332"/>
+          </a:xfrm>
+          <a:prstGeom prst="rect">
+            <a:avLst/>
+          </a:prstGeom>
+          <a:noFill/>
+        </p:spPr>
+        <p:txBody>
+          <a:bodyPr wrap="square" rtlCol="0">
+            <a:spAutoFit/>
+          </a:bodyPr>
+          <a:lstStyle/>
+          <a:p>
+            <a:r>
+              <a:rPr lang="en-BE" dirty="0"/>
+              <a:t>1</a:t>
+            </a:r>
+          </a:p>
+        </p:txBody>
+      </p:sp>
+      <p:sp>
+        <p:nvSpPr>
+          <p:cNvPr id="33" name="TextBox 32">
+            <a:extLst>
+              <a:ext uri="{FF2B5EF4-FFF2-40B4-BE49-F238E27FC236}">
+                <a16:creationId xmlns:a16="http://schemas.microsoft.com/office/drawing/2014/main" id="{AC9D877D-2878-433F-36C0-B114912A0853}"/>
+              </a:ext>
+            </a:extLst>
+          </p:cNvPr>
+          <p:cNvSpPr txBox="1"/>
+          <p:nvPr/>
+        </p:nvSpPr>
+        <p:spPr>
+          <a:xfrm>
+            <a:off x="9012082" y="5888179"/>
+            <a:ext cx="332509" cy="369332"/>
+          </a:xfrm>
+          <a:prstGeom prst="rect">
+            <a:avLst/>
+          </a:prstGeom>
+          <a:noFill/>
+        </p:spPr>
+        <p:txBody>
+          <a:bodyPr wrap="square" rtlCol="0">
+            <a:spAutoFit/>
+          </a:bodyPr>
+          <a:lstStyle/>
+          <a:p>
+            <a:r>
+              <a:rPr lang="en-BE" dirty="0"/>
+              <a:t>1</a:t>
+            </a:r>
+          </a:p>
+        </p:txBody>
+      </p:sp>
+      <p:sp>
+        <p:nvSpPr>
+          <p:cNvPr id="34" name="TextBox 33">
+            <a:extLst>
+              <a:ext uri="{FF2B5EF4-FFF2-40B4-BE49-F238E27FC236}">
+                <a16:creationId xmlns:a16="http://schemas.microsoft.com/office/drawing/2014/main" id="{648C36E2-B36B-17EE-709B-694DDFC2A9BE}"/>
+              </a:ext>
+            </a:extLst>
+          </p:cNvPr>
+          <p:cNvSpPr txBox="1"/>
+          <p:nvPr/>
+        </p:nvSpPr>
+        <p:spPr>
+          <a:xfrm>
+            <a:off x="10480666" y="5181576"/>
+            <a:ext cx="332509" cy="369332"/>
+          </a:xfrm>
+          <a:prstGeom prst="rect">
+            <a:avLst/>
+          </a:prstGeom>
+          <a:noFill/>
+        </p:spPr>
+        <p:txBody>
+          <a:bodyPr wrap="square" rtlCol="0">
+            <a:spAutoFit/>
+          </a:bodyPr>
+          <a:lstStyle/>
+          <a:p>
+            <a:r>
+              <a:rPr lang="en-BE" dirty="0"/>
+              <a:t>N</a:t>
+            </a:r>
+          </a:p>
+        </p:txBody>
+      </p:sp>
+      <p:sp>
+        <p:nvSpPr>
+          <p:cNvPr id="35" name="TextBox 34">
+            <a:extLst>
+              <a:ext uri="{FF2B5EF4-FFF2-40B4-BE49-F238E27FC236}">
+                <a16:creationId xmlns:a16="http://schemas.microsoft.com/office/drawing/2014/main" id="{9266026C-0B3E-E8AE-418F-5B5684811D89}"/>
+              </a:ext>
+            </a:extLst>
+          </p:cNvPr>
+          <p:cNvSpPr txBox="1"/>
+          <p:nvPr/>
+        </p:nvSpPr>
+        <p:spPr>
+          <a:xfrm>
+            <a:off x="6476708" y="5486371"/>
+            <a:ext cx="332509" cy="369332"/>
+          </a:xfrm>
+          <a:prstGeom prst="rect">
+            <a:avLst/>
+          </a:prstGeom>
+          <a:noFill/>
+        </p:spPr>
+        <p:txBody>
+          <a:bodyPr wrap="square" rtlCol="0">
+            <a:spAutoFit/>
+          </a:bodyPr>
+          <a:lstStyle/>
+          <a:p>
+            <a:r>
+              <a:rPr lang="en-BE" dirty="0"/>
+              <a:t>N</a:t>
+            </a:r>
+          </a:p>
+        </p:txBody>
+      </p:sp>
+      <p:sp>
+        <p:nvSpPr>
+          <p:cNvPr id="36" name="TextBox 35">
+            <a:extLst>
+              <a:ext uri="{FF2B5EF4-FFF2-40B4-BE49-F238E27FC236}">
+                <a16:creationId xmlns:a16="http://schemas.microsoft.com/office/drawing/2014/main" id="{661958D6-3B7A-4B96-A5AF-11A8FB1DF613}"/>
+              </a:ext>
+            </a:extLst>
+          </p:cNvPr>
+          <p:cNvSpPr txBox="1"/>
+          <p:nvPr/>
+        </p:nvSpPr>
+        <p:spPr>
+          <a:xfrm>
+            <a:off x="3137774" y="6068261"/>
+            <a:ext cx="332509" cy="369332"/>
+          </a:xfrm>
+          <a:prstGeom prst="rect">
+            <a:avLst/>
+          </a:prstGeom>
+          <a:noFill/>
+        </p:spPr>
+        <p:txBody>
+          <a:bodyPr wrap="square" rtlCol="0">
+            <a:spAutoFit/>
+          </a:bodyPr>
+          <a:lstStyle/>
+          <a:p>
+            <a:r>
+              <a:rPr lang="en-BE" dirty="0"/>
+              <a:t>N</a:t>
             </a:r>
           </a:p>
         </p:txBody>

</xml_diff>